<commit_message>
Fix broken link in wk-01 slides.
</commit_message>
<xml_diff>
--- a/docs/slides/wk-01-2026-01-15-intro.pptx
+++ b/docs/slides/wk-01-2026-01-15-intro.pptx
@@ -9956,6 +9956,30 @@
                 <a:hlinkClick r:id="rId3"/>
               </a:rPr>
               <a:t>Exercise ANAT</a:t>
+            </a:r>
+            <a:r>
+              <a:rPr/>
+              <a:t> | </a:t>
+            </a:r>
+            <a:r>
+              <a:rPr>
+                <a:hlinkClick r:id="rId4"/>
+              </a:rPr>
+              <a:t>docx</a:t>
+            </a:r>
+            <a:r>
+              <a:rPr/>
+              <a:t> | </a:t>
+            </a:r>
+            <a:r>
+              <a:rPr>
+                <a:hlinkClick r:id="rId5"/>
+              </a:rPr>
+              <a:t>pdf</a:t>
+            </a:r>
+            <a:r>
+              <a:rPr/>
+              <a:t> |</a:t>
             </a:r>
           </a:p>
         </p:txBody>

</xml_diff>